<commit_message>
Deck MU: nama anggota di slide judul dibagi dua baris agar tetap di area gelap
Co-Authored-By: Claude Fable 5.1 <noreply@anthropic.com>
Claude-Session: https://claude.ai/code/session_0181gbGC86KAwEhLxnoy9ZTa
</commit_message>
<xml_diff>
--- a/materi-strategic-management/presentasi/SMJKT_Group 4_Case Manchester United_desain MU.pptx
+++ b/materi-strategic-management/presentasi/SMJKT_Group 4_Case Manchester United_desain MU.pptx
@@ -4365,19 +4365,22 @@
         <p:spPr>
           <a:xfrm>
             <a:off x="3931920" y="5669280"/>
-            <a:ext cx="7589520" cy="502920"/>
-          </a:xfrm>
-          <a:prstGeom prst="rect">
-            <a:avLst/>
-          </a:prstGeom>
-          <a:noFill/>
-          <a:ln/>
-        </p:spPr>
-        <p:txBody>
-          <a:bodyPr wrap="square" lIns="0" tIns="0" rIns="0" bIns="0" rtlCol="0" anchor="t"/>
-          <a:lstStyle/>
-          <a:p>
-            <a:pPr indent="0" marL="0">
+            <a:ext cx="5303520" cy="640080"/>
+          </a:xfrm>
+          <a:prstGeom prst="rect">
+            <a:avLst/>
+          </a:prstGeom>
+          <a:noFill/>
+          <a:ln/>
+        </p:spPr>
+        <p:txBody>
+          <a:bodyPr wrap="square" lIns="0" tIns="0" rIns="0" bIns="0" rtlCol="0" anchor="t"/>
+          <a:lstStyle/>
+          <a:p>
+            <a:pPr indent="0" marL="0">
+              <a:lnSpc>
+                <a:spcPct val="115000"/>
+              </a:lnSpc>
               <a:buNone/>
             </a:pPr>
             <a:r>
@@ -4389,7 +4392,27 @@
                 <a:ea typeface="Poppins Medium" pitchFamily="34" charset="-122"/>
                 <a:cs typeface="Poppins Medium" pitchFamily="34" charset="-120"/>
               </a:rPr>
-              <a:t>Fitra Aidila  ·  Aulia Sisca Rahmadiyanti  ·  Bagaskoro  ·  Imam Prayudha  ·  Tegar Awanto</a:t>
+              <a:t>Fitra Aidila  ·  Aulia Sisca Rahmadiyanti  ·  Bagaskoro</a:t>
+            </a:r>
+            <a:endParaRPr lang="en-US" sz="1100" dirty="0"/>
+          </a:p>
+          <a:p>
+            <a:pPr indent="0" marL="0">
+              <a:lnSpc>
+                <a:spcPct val="115000"/>
+              </a:lnSpc>
+              <a:buNone/>
+            </a:pPr>
+            <a:r>
+              <a:rPr lang="en-US" sz="1100" dirty="0">
+                <a:solidFill>
+                  <a:srgbClr val="FFFFFF"/>
+                </a:solidFill>
+                <a:latin typeface="Poppins Medium" pitchFamily="34" charset="0"/>
+                <a:ea typeface="Poppins Medium" pitchFamily="34" charset="-122"/>
+                <a:cs typeface="Poppins Medium" pitchFamily="34" charset="-120"/>
+              </a:rPr>
+              <a:t>Imam Prayudha  ·  Tegar Awanto</a:t>
             </a:r>
             <a:endParaRPr lang="en-US" sz="1100" dirty="0"/>
           </a:p>

</xml_diff>